<commit_message>
chore(preview): secteur_Healthcare_S&P_500 outputs regeneres
</commit_message>
<xml_diff>
--- a/preview/secteur_Healthcare_S&P_500/secteur_Healthcare_S&P_500.pptx
+++ b/preview/secteur_Healthcare_S&P_500/secteur_Healthcare_S&P_500.pptx
@@ -8172,7 +8172,7 @@
                   <a:srgbClr val="555555"/>
                 </a:solidFill>
               </a:rPr>
-              <a:t>Les avancées en biotechnologie et thérapies géniques (ex : CAR-T) stimulent les pipelines des leaders comme JNJ et MRK.</a:t>
+              <a:t>Les avancées en thérapies géniques et cellulaires (ex : CAR-T) pourraient relancer la croissance organique des acteurs comme TMO.</a:t>
             </a:r>
           </a:p>
         </p:txBody>
@@ -8326,7 +8326,7 @@
                   <a:srgbClr val="555555"/>
                 </a:solidFill>
               </a:rPr>
-              <a:t>Les changements législatifs (ex : contrôle des prix en Europe) pourraient éroder les marges des laboratoires.</a:t>
+              <a:t>Les réformes sur les prix des médicaments (ex : Medicare) pourraient éroder les marges des acteurs historiques.</a:t>
             </a:r>
           </a:p>
         </p:txBody>
@@ -9189,7 +9189,7 @@
                   <a:srgbClr val="555555"/>
                 </a:solidFill>
               </a:rPr>
-              <a:t>Le vieillissement de la population et l'augmentation des maladies chroniques soutiennent une demande récurrente pour les produits pharmaceutiques et dispositifs</a:t>
+              <a:t>Un assouplissement des contraintes de prix aux États-Unis (ex : Inflation Reduction Act) bénéficierait aux grands laboratoires comme JNJ.</a:t>
             </a:r>
           </a:p>
         </p:txBody>
@@ -9343,7 +9343,7 @@
                   <a:srgbClr val="555555"/>
                 </a:solidFill>
               </a:rPr>
-              <a:t>La perte de brevets sur des blockbusters (ex : Keytruda pour MRK) expose le secteur à une pression sur les prix.</a:t>
+              <a:t>L'émergence de biosimilaires et de génériques exerce une pression à la baisse sur les prix des blockbusters.</a:t>
             </a:r>
           </a:p>
         </p:txBody>
@@ -10206,7 +10206,7 @@
                   <a:srgbClr val="555555"/>
                 </a:solidFill>
               </a:rPr>
-              <a:t>Les réformes favorables aux prix des médicaments aux États-Unis (ex : Inflation Reduction Act) pourraient réduire les pressions réglementaires sur les géants ph</a:t>
+              <a:t>Le vieillissement de la population mondiale et l'augmentation des maladies chroniques soutiennent la demande en médicaments et dispositifs médicaux.</a:t>
             </a:r>
           </a:p>
         </p:txBody>
@@ -10360,7 +10360,7 @@
                   <a:srgbClr val="555555"/>
                 </a:solidFill>
               </a:rPr>
-              <a:t>Les pandémies ou pénuries de matières premières (ex : crise du COVID-19) perturbent les chaînes d'approvisionnement et les coûts de production.</a:t>
+              <a:t>Les litiges liés aux opioïdes ou aux dispositifs médicaux (ex : Johnson &amp; Johnson) représentent un passif financier significatif.</a:t>
             </a:r>
           </a:p>
         </p:txBody>
@@ -14360,7 +14360,7 @@
                   <a:srgbClr val="555555"/>
                 </a:solidFill>
               </a:rPr>
-              <a:t>Les changements législatifs (ex : contrôle des prix en Europe) pourraient éroder les marges des laboratoires.</a:t>
+              <a:t>Les réformes sur les prix des médicaments (ex : Medicare) pourraient éroder les marges des acteurs historiques.</a:t>
             </a:r>
           </a:p>
         </p:txBody>
@@ -14480,7 +14480,7 @@
                   <a:srgbClr val="FFFFFF"/>
                 </a:solidFill>
               </a:rPr>
-              <a:t>Concurrence des génériques</a:t>
+              <a:t>Concurrence</a:t>
             </a:r>
           </a:p>
         </p:txBody>
@@ -14514,7 +14514,7 @@
                   <a:srgbClr val="555555"/>
                 </a:solidFill>
               </a:rPr>
-              <a:t>La perte de brevets sur des blockbusters (ex : Keytruda pour MRK) expose le secteur à une pression sur les prix.</a:t>
+              <a:t>L'émergence de biosimilaires et de génériques exerce une pression à la baisse sur les prix des blockbusters.</a:t>
             </a:r>
           </a:p>
         </p:txBody>
@@ -14634,7 +14634,7 @@
                   <a:srgbClr val="FFFFFF"/>
                 </a:solidFill>
               </a:rPr>
-              <a:t>Crises sanitaires</a:t>
+              <a:t>Risque juridique</a:t>
             </a:r>
           </a:p>
         </p:txBody>
@@ -14668,7 +14668,7 @@
                   <a:srgbClr val="555555"/>
                 </a:solidFill>
               </a:rPr>
-              <a:t>Les pandémies ou pénuries de matières premières (ex : crise du COVID-19) perturbent les chaînes d'approvisionnement et les coûts de production.</a:t>
+              <a:t>Les litiges liés aux opioïdes ou aux dispositifs médicaux (ex : Johnson &amp; Johnson) représentent un passif financier significatif.</a:t>
             </a:r>
           </a:p>
         </p:txBody>
@@ -16921,7 +16921,7 @@
                   <a:srgbClr val="555555"/>
                 </a:solidFill>
               </a:rPr>
-              <a:t>+ Innovation thérapeutique — Les avancées en biotechnologie et thérapies géniques (ex : CAR-T) stimulent les pipelines des leaders comme JNJ et MRK.</a:t>
+              <a:t>+ Innovation thérapeutique — Les avancées en thérapies géniques et cellulaires (ex : CAR-T) pourraient relancer la croissance organique des acteurs comme TMO.</a:t>
             </a:r>
           </a:p>
         </p:txBody>
@@ -17041,7 +17041,7 @@
                   <a:srgbClr val="555555"/>
                 </a:solidFill>
               </a:rPr>
-              <a:t>- Réglementation — Les changements législatifs (ex : contrôle des prix en Europe) pourraient éroder les marges des laboratoires.</a:t>
+              <a:t>- Réglementation — Les réformes sur les prix des médicaments (ex : Medicare) pourraient éroder les marges des acteurs historiques.</a:t>
             </a:r>
           </a:p>
         </p:txBody>
@@ -19627,7 +19627,7 @@
                   <a:srgbClr val="555555"/>
                 </a:solidFill>
               </a:rPr>
-              <a:t>Les avancées en biotechnologie et thérapies géniques (ex : CAR-T) stimulent les pipelines des leaders comme JNJ et MRK.</a:t>
+              <a:t>Les avancées en thérapies géniques et cellulaires (ex : CAR-T) pourraient relancer la croissance organique des acteurs comme TMO.</a:t>
             </a:r>
           </a:p>
         </p:txBody>
@@ -19747,7 +19747,7 @@
                   <a:srgbClr val="1B3A6B"/>
                 </a:solidFill>
               </a:rPr>
-              <a:t>Demande structurelle</a:t>
+              <a:t>Politiques de prix</a:t>
             </a:r>
           </a:p>
         </p:txBody>
@@ -19781,7 +19781,7 @@
                   <a:srgbClr val="555555"/>
                 </a:solidFill>
               </a:rPr>
-              <a:t>Le vieillissement de la population et l'augmentation des maladies chroniques soutiennent une demande récurrente pour les produits pharmaceutiques et dispositifs médicaux.</a:t>
+              <a:t>Un assouplissement des contraintes de prix aux États-Unis (ex : Inflation Reduction Act) bénéficierait aux grands laboratoires comme JNJ.</a:t>
             </a:r>
           </a:p>
         </p:txBody>
@@ -19901,7 +19901,7 @@
                   <a:srgbClr val="1B3A6B"/>
                 </a:solidFill>
               </a:rPr>
-              <a:t>Politiques publiques</a:t>
+              <a:t>Demande structurelle</a:t>
             </a:r>
           </a:p>
         </p:txBody>
@@ -19935,7 +19935,7 @@
                   <a:srgbClr val="555555"/>
                 </a:solidFill>
               </a:rPr>
-              <a:t>Les réformes favorables aux prix des médicaments aux États-Unis (ex : Inflation Reduction Act) pourraient réduire les pressions réglementaires sur les géants pharmaceutiques.</a:t>
+              <a:t>Le vieillissement de la population mondiale et l'augmentation des maladies chroniques soutiennent la demande en médicaments et dispositifs médicaux.</a:t>
             </a:r>
           </a:p>
         </p:txBody>
@@ -20166,7 +20166,7 @@
                   <a:srgbClr val="555555"/>
                 </a:solidFill>
               </a:rPr>
-              <a:t>Les changements législatifs (ex : contrôle des prix en Europe) pourraient éroder les marges des laboratoires.</a:t>
+              <a:t>Les réformes sur les prix des médicaments (ex : Medicare) pourraient éroder les marges des acteurs historiques.</a:t>
             </a:r>
           </a:p>
         </p:txBody>
@@ -20286,7 +20286,7 @@
                   <a:srgbClr val="A82020"/>
                 </a:solidFill>
               </a:rPr>
-              <a:t>Concurrence des génériques</a:t>
+              <a:t>Concurrence</a:t>
             </a:r>
           </a:p>
         </p:txBody>
@@ -20320,7 +20320,7 @@
                   <a:srgbClr val="555555"/>
                 </a:solidFill>
               </a:rPr>
-              <a:t>La perte de brevets sur des blockbusters (ex : Keytruda pour MRK) expose le secteur à une pression sur les prix.</a:t>
+              <a:t>L'émergence de biosimilaires et de génériques exerce une pression à la baisse sur les prix des blockbusters.</a:t>
             </a:r>
           </a:p>
         </p:txBody>
@@ -20440,7 +20440,7 @@
                   <a:srgbClr val="A82020"/>
                 </a:solidFill>
               </a:rPr>
-              <a:t>Crises sanitaires</a:t>
+              <a:t>Risque juridique</a:t>
             </a:r>
           </a:p>
         </p:txBody>
@@ -20474,7 +20474,7 @@
                   <a:srgbClr val="555555"/>
                 </a:solidFill>
               </a:rPr>
-              <a:t>Les pandémies ou pénuries de matières premières (ex : crise du COVID-19) perturbent les chaînes d'approvisionnement et les coûts de production.</a:t>
+              <a:t>Les litiges liés aux opioïdes ou aux dispositifs médicaux (ex : Johnson &amp; Johnson) représentent un passif financier significatif.</a:t>
             </a:r>
           </a:p>
         </p:txBody>
@@ -24697,7 +24697,7 @@
                   <a:srgbClr val="555555"/>
                 </a:solidFill>
               </a:rPr>
-              <a:t>Le secteur Healthcare affiche une valorisation modérée à 15.1x EV/EBITDA, alignée sur sa médiane historique malgré une croissance des revenus de +6.1% et un momentum 52 semaines positif de +11.9%. Les marges EBITDA à 33.9% reflètent une discipline opérationnelle solide dans un environnement réglementaire et concurrentiel exigeant.</a:t>
+              <a:t>Le secteur Healthcare affiche une valorisation modérée avec un multiple EV/EBITDA médian de 15.1x, légèrement au-dessus de sa moyenne historique, reflétant une confiance modérée des investisseurs malgré des pressions réglementaires persistantes. La marge EBITDA médiane de 33.9% souligne une résilience opérationnelle, mais la croissance des revenus à +6.1% reste en deçà des attentes post-pandémie.</a:t>
             </a:r>
           </a:p>
         </p:txBody>
@@ -24885,7 +24885,7 @@
                   <a:srgbClr val="555555"/>
                 </a:solidFill>
               </a:rPr>
-              <a:t>Les avancées en biotechnologie et thérapies géniques (ex : CAR-T) stimulent les pipelines des leaders comme JNJ et MRK.</a:t>
+              <a:t>Les avancées en thérapies géniques et cellulaires (ex : CAR-T) pourraient relancer la croissance organique des acteurs comme TMO.</a:t>
             </a:r>
           </a:p>
         </p:txBody>
@@ -24962,7 +24962,7 @@
                   <a:srgbClr val="1B3A6B"/>
                 </a:solidFill>
               </a:rPr>
-              <a:t>Demande structurelle</a:t>
+              <a:t>Politiques de prix</a:t>
             </a:r>
           </a:p>
         </p:txBody>
@@ -24996,7 +24996,7 @@
                   <a:srgbClr val="555555"/>
                 </a:solidFill>
               </a:rPr>
-              <a:t>Le vieillissement de la population et l'augmentation des maladies chroniques soutiennent une demande récurrente pour les produits pharmaceutiques et dispositifs médicaux.</a:t>
+              <a:t>Un assouplissement des contraintes de prix aux États-Unis (ex : Inflation Reduction Act) bénéficierait aux grands laboratoires comme JNJ.</a:t>
             </a:r>
           </a:p>
         </p:txBody>
@@ -25073,7 +25073,7 @@
                   <a:srgbClr val="1B3A6B"/>
                 </a:solidFill>
               </a:rPr>
-              <a:t>Politiques publiques</a:t>
+              <a:t>Demande structurelle</a:t>
             </a:r>
           </a:p>
         </p:txBody>
@@ -25107,7 +25107,7 @@
                   <a:srgbClr val="555555"/>
                 </a:solidFill>
               </a:rPr>
-              <a:t>Les réformes favorables aux prix des médicaments aux États-Unis (ex : Inflation Reduction Act) pourraient réduire les pressions réglementaires sur les géants pharmaceutiques.</a:t>
+              <a:t>Le vieillissement de la population mondiale et l'augmentation des maladies chroniques soutiennent la demande en médicaments et dispositifs médicaux.</a:t>
             </a:r>
           </a:p>
         </p:txBody>
@@ -28637,7 +28637,7 @@
                   <a:srgbClr val="555555"/>
                 </a:solidFill>
               </a:rPr>
-              <a:t>Les acquisitions ciblées (ex : rachat de licences ou startups biotech) renforcent les pipelines des acteurs établis comme TMO.</a:t>
+              <a:t>Les acquisitions ciblées dans les biotechs innovantes (ex : MRK avec Acceleron) pourraient stimuler la croissance externe.</a:t>
             </a:r>
           </a:p>
         </p:txBody>
@@ -28825,7 +28825,7 @@
                   <a:srgbClr val="555555"/>
                 </a:solidFill>
               </a:rPr>
-              <a:t>L'accès aux marchés émergents (Chine, Inde) offre un potentiel de croissance à deux chiffres pour les vaccins et dispositifs.</a:t>
+              <a:t>L'entrée sur des marchés émergents (ex : Asie du Sud-Est) offre un potentiel de croissance à deux chiffres.</a:t>
             </a:r>
           </a:p>
         </p:txBody>
@@ -29013,7 +29013,7 @@
                   <a:srgbClr val="555555"/>
                 </a:solidFill>
               </a:rPr>
-              <a:t>L'augmentation des dépenses en R&amp;D (ex : +8% par an chez les big pharma) pèse sur les marges à court terme.</a:t>
+              <a:t>L'augmentation des dépenses en R&amp;D (ex : +12% chez JNJ en 2023) pèse sur les marges à court terme.</a:t>
             </a:r>
           </a:p>
         </p:txBody>
@@ -29201,7 +29201,7 @@
                   <a:srgbClr val="555555"/>
                 </a:solidFill>
               </a:rPr>
-              <a:t>Les conflits commerciaux (ex : restrictions sur les exportations de technologies médicales) ralentissent les collaborations internationales.</a:t>
+              <a:t>Les ruptures d'approvisionnement en principes actifs (ex : Chine/Inde) pourraient perturber les chaînes de production.</a:t>
             </a:r>
           </a:p>
         </p:txBody>
@@ -29525,7 +29525,7 @@
                   <a:srgbClr val="2A5298"/>
                 </a:solidFill>
               </a:rPr>
-              <a:t>Le secteur évolue en phase de maturité avancée avec des opportunités de croissance sélective dans les niches innovantes.</a:t>
+              <a:t>Le secteur évolue dans une phase de maturité avancée, avec des opportunités limitées mais des barrières à l'entrée élevées pour les nouveaux entrants.</a:t>
             </a:r>
           </a:p>
         </p:txBody>

</xml_diff>